<commit_message>
Update downloadable deck files and build scripts with latest content
</commit_message>
<xml_diff>
--- a/public/TM-Pick-n-Pay-Express.pptx
+++ b/public/TM-Pick-n-Pay-Express.pptx
@@ -25129,59 +25129,32 @@
       </p:sp>
       <p:sp>
         <p:nvSpPr>
-          <p:cNvPr id="11" name="Shape 7"/>
+          <p:cNvPr id="11" name="Text 7"/>
           <p:cNvSpPr/>
           <p:nvPr/>
         </p:nvSpPr>
         <p:spPr>
           <a:xfrm>
             <a:off x="621792" y="1947672"/>
-            <a:ext cx="1600200" cy="274320"/>
-          </a:xfrm>
-          <a:prstGeom prst="roundRect">
-            <a:avLst>
-              <a:gd name="adj" fmla="val 50000"/>
-            </a:avLst>
-          </a:prstGeom>
-          <a:solidFill>
-            <a:srgbClr val="FFFFFF"/>
-          </a:solidFill>
-          <a:ln w="12700">
-            <a:solidFill>
-              <a:srgbClr val="FFFFFF"/>
-            </a:solidFill>
-            <a:prstDash val="solid"/>
-          </a:ln>
-        </p:spPr>
-      </p:sp>
-      <p:sp>
-        <p:nvSpPr>
-          <p:cNvPr id="12" name="Text 8"/>
-          <p:cNvSpPr/>
-          <p:nvPr/>
-        </p:nvSpPr>
-        <p:spPr>
-          <a:xfrm>
-            <a:off x="621792" y="1947672"/>
-            <a:ext cx="1600200" cy="274320"/>
-          </a:xfrm>
-          <a:prstGeom prst="rect">
-            <a:avLst/>
-          </a:prstGeom>
-          <a:noFill/>
-          <a:ln/>
-        </p:spPr>
-        <p:txBody>
-          <a:bodyPr wrap="square" lIns="0" tIns="0" rIns="0" bIns="0" rtlCol="0" anchor="ctr"/>
-          <a:lstStyle/>
-          <a:p>
-            <a:pPr algn="ctr" indent="0" marL="0">
-              <a:buNone/>
-            </a:pPr>
-            <a:r>
-              <a:rPr lang="en-US" sz="950" b="1" dirty="0">
-                <a:solidFill>
-                  <a:srgbClr val="A50C2D"/>
+            <a:ext cx="4251960" cy="320040"/>
+          </a:xfrm>
+          <a:prstGeom prst="rect">
+            <a:avLst/>
+          </a:prstGeom>
+          <a:noFill/>
+          <a:ln/>
+        </p:spPr>
+        <p:txBody>
+          <a:bodyPr wrap="square" lIns="0" tIns="0" rIns="0" bIns="0" rtlCol="0" anchor="t"/>
+          <a:lstStyle/>
+          <a:p>
+            <a:pPr indent="0" marL="0">
+              <a:buNone/>
+            </a:pPr>
+            <a:r>
+              <a:rPr lang="en-US" sz="1300" b="1" dirty="0">
+                <a:solidFill>
+                  <a:srgbClr val="FFFFFF"/>
                 </a:solidFill>
                 <a:latin typeface="Calibri" pitchFamily="34" charset="0"/>
                 <a:ea typeface="Calibri" pitchFamily="34" charset="-122"/>
@@ -25189,13 +25162,13 @@
               </a:rPr>
               <a:t>Market leadership</a:t>
             </a:r>
-            <a:endParaRPr lang="en-US" sz="950" dirty="0"/>
-          </a:p>
-        </p:txBody>
-      </p:sp>
-      <p:sp>
-        <p:nvSpPr>
-          <p:cNvPr id="13" name="Text 9"/>
+            <a:endParaRPr lang="en-US" sz="1300" dirty="0"/>
+          </a:p>
+        </p:txBody>
+      </p:sp>
+      <p:sp>
+        <p:nvSpPr>
+          <p:cNvPr id="12" name="Text 8"/>
           <p:cNvSpPr/>
           <p:nvPr/>
         </p:nvSpPr>
@@ -25234,7 +25207,7 @@
       </p:sp>
       <p:sp>
         <p:nvSpPr>
-          <p:cNvPr id="14" name="Shape 10"/>
+          <p:cNvPr id="13" name="Shape 9"/>
           <p:cNvSpPr/>
           <p:nvPr/>
         </p:nvSpPr>
@@ -25261,59 +25234,32 @@
       </p:sp>
       <p:sp>
         <p:nvSpPr>
-          <p:cNvPr id="15" name="Shape 11"/>
+          <p:cNvPr id="14" name="Text 10"/>
           <p:cNvSpPr/>
           <p:nvPr/>
         </p:nvSpPr>
         <p:spPr>
           <a:xfrm>
             <a:off x="621792" y="3319272"/>
-            <a:ext cx="1600200" cy="274320"/>
-          </a:xfrm>
-          <a:prstGeom prst="roundRect">
-            <a:avLst>
-              <a:gd name="adj" fmla="val 50000"/>
-            </a:avLst>
-          </a:prstGeom>
-          <a:solidFill>
-            <a:srgbClr val="FFFFFF"/>
-          </a:solidFill>
-          <a:ln w="12700">
-            <a:solidFill>
-              <a:srgbClr val="FFFFFF"/>
-            </a:solidFill>
-            <a:prstDash val="solid"/>
-          </a:ln>
-        </p:spPr>
-      </p:sp>
-      <p:sp>
-        <p:nvSpPr>
-          <p:cNvPr id="16" name="Text 12"/>
-          <p:cNvSpPr/>
-          <p:nvPr/>
-        </p:nvSpPr>
-        <p:spPr>
-          <a:xfrm>
-            <a:off x="621792" y="3319272"/>
-            <a:ext cx="1600200" cy="274320"/>
-          </a:xfrm>
-          <a:prstGeom prst="rect">
-            <a:avLst/>
-          </a:prstGeom>
-          <a:noFill/>
-          <a:ln/>
-        </p:spPr>
-        <p:txBody>
-          <a:bodyPr wrap="square" lIns="0" tIns="0" rIns="0" bIns="0" rtlCol="0" anchor="ctr"/>
-          <a:lstStyle/>
-          <a:p>
-            <a:pPr algn="ctr" indent="0" marL="0">
-              <a:buNone/>
-            </a:pPr>
-            <a:r>
-              <a:rPr lang="en-US" sz="950" b="1" dirty="0">
-                <a:solidFill>
-                  <a:srgbClr val="A50C2D"/>
+            <a:ext cx="4251960" cy="320040"/>
+          </a:xfrm>
+          <a:prstGeom prst="rect">
+            <a:avLst/>
+          </a:prstGeom>
+          <a:noFill/>
+          <a:ln/>
+        </p:spPr>
+        <p:txBody>
+          <a:bodyPr wrap="square" lIns="0" tIns="0" rIns="0" bIns="0" rtlCol="0" anchor="t"/>
+          <a:lstStyle/>
+          <a:p>
+            <a:pPr indent="0" marL="0">
+              <a:buNone/>
+            </a:pPr>
+            <a:r>
+              <a:rPr lang="en-US" sz="1300" b="1" dirty="0">
+                <a:solidFill>
+                  <a:srgbClr val="FFFFFF"/>
                 </a:solidFill>
                 <a:latin typeface="Calibri" pitchFamily="34" charset="0"/>
                 <a:ea typeface="Calibri" pitchFamily="34" charset="-122"/>
@@ -25321,13 +25267,13 @@
               </a:rPr>
               <a:t>Maximising group assets</a:t>
             </a:r>
-            <a:endParaRPr lang="en-US" sz="950" dirty="0"/>
-          </a:p>
-        </p:txBody>
-      </p:sp>
-      <p:sp>
-        <p:nvSpPr>
-          <p:cNvPr id="17" name="Text 13"/>
+            <a:endParaRPr lang="en-US" sz="1300" dirty="0"/>
+          </a:p>
+        </p:txBody>
+      </p:sp>
+      <p:sp>
+        <p:nvSpPr>
+          <p:cNvPr id="15" name="Text 11"/>
           <p:cNvSpPr/>
           <p:nvPr/>
         </p:nvSpPr>

</xml_diff>